<commit_message>
docs(t1): statistiques du deck alignees sur le code (3246 lignes, 135 tests)
</commit_message>
<xml_diff>
--- a/T1-PouvoirCoalition-IliasKalalou-KaelanGrall/presentation.pptx
+++ b/T1-PouvoirCoalition-IliasKalalou-KaelanGrall/presentation.pptx
@@ -3806,7 +3806,7 @@
                   <a:srgbClr val="333333"/>
                 </a:solidFill>
               </a:rPr>
-              <a:t>131 tests : instances de référence et concordance</a:t>
+              <a:t>135 tests : instances de référence et concordance</a:t>
             </a:r>
             <a:endParaRPr lang="en-US" sz="1200" dirty="0"/>
           </a:p>
@@ -3908,7 +3908,7 @@
                 <a:ea typeface="Georgia" pitchFamily="34" charset="-122"/>
                 <a:cs typeface="Georgia" pitchFamily="34" charset="-120"/>
               </a:rPr>
-              <a:t>3107</a:t>
+              <a:t>3246</a:t>
             </a:r>
             <a:endParaRPr lang="en-US" sz="2600" dirty="0"/>
           </a:p>
@@ -3983,7 +3983,7 @@
                 <a:ea typeface="Georgia" pitchFamily="34" charset="-122"/>
                 <a:cs typeface="Georgia" pitchFamily="34" charset="-120"/>
               </a:rPr>
-              <a:t>131</a:t>
+              <a:t>135</a:t>
             </a:r>
             <a:endParaRPr lang="en-US" sz="2600" dirty="0"/>
           </a:p>

</xml_diff>